<commit_message>
fix: correct KPI chip figures on slide 2 to match FY2025 raw data
Four hard-coded values in the introduction slide were stale and did not
match the official SEC companyfacts figures stored in RAW_DATA.md:
- Visa Revenue: $39.1bn → $40.0bn
- Visa Net Income: $19.6bn → $20.1bn
- Mastercard Revenue: $32.0bn → $32.8bn
- Mastercard Net Income: $14.6bn → $15.0bn

All 17 ratio calculations (profitability, liquidity, leverage, efficiency,
market) were verified against the raw data and are correct.
Deliverables rebuilt from the corrected build script.

https://claude.ai/code/session_01ApoehNC8YKQsnnTC8bNqP3
</commit_message>
<xml_diff>
--- a/deliverables/visa_vs_mastercard_presentation.pptx
+++ b/deliverables/visa_vs_mastercard_presentation.pptx
@@ -3761,7 +3761,7 @@
               </a:defRPr>
             </a:pPr>
             <a:r>
-              <a:t>$39.1bn</a:t>
+              <a:t>$40.0bn</a:t>
             </a:r>
           </a:p>
         </p:txBody>
@@ -3827,7 +3827,7 @@
               </a:defRPr>
             </a:pPr>
             <a:r>
-              <a:t>$19.6bn</a:t>
+              <a:t>$20.1bn</a:t>
             </a:r>
           </a:p>
         </p:txBody>
@@ -3893,7 +3893,7 @@
               </a:defRPr>
             </a:pPr>
             <a:r>
-              <a:t>$32.0bn</a:t>
+              <a:t>$32.8bn</a:t>
             </a:r>
           </a:p>
         </p:txBody>
@@ -3959,7 +3959,7 @@
               </a:defRPr>
             </a:pPr>
             <a:r>
-              <a:t>$14.6bn</a:t>
+              <a:t>$15.0bn</a:t>
             </a:r>
           </a:p>
         </p:txBody>

</xml_diff>